<commit_message>
Theme V7 slide 8 for Honeywell deck
Co-authored-by: Shyam <shyam.nexus@gmail.com>
</commit_message>
<xml_diff>
--- a/AI-Driven Embedded Product Lifecycle OrchestratorV7.pptx
+++ b/AI-Driven Embedded Product Lifecycle OrchestratorV7.pptx
@@ -56929,7 +56929,7 @@
             <a:avLst/>
           </a:prstGeom>
           <a:solidFill>
-            <a:srgbClr val="020A1A"/>
+            <a:srgbClr val="111111"/>
           </a:solidFill>
           <a:ln>
             <a:noFill/>
@@ -56983,7 +56983,7 @@
             <a:avLst/>
           </a:prstGeom>
           <a:solidFill>
-            <a:srgbClr val="FF8C00"/>
+            <a:srgbClr val="D71920"/>
           </a:solidFill>
           <a:ln>
             <a:noFill/>
@@ -57033,7 +57033,7 @@
             <a:avLst/>
           </a:prstGeom>
           <a:solidFill>
-            <a:srgbClr val="FF8C00"/>
+            <a:srgbClr val="D71920"/>
           </a:solidFill>
           <a:ln>
             <a:noFill/>
@@ -57083,6 +57083,7 @@
             <a:avLst/>
           </a:prstGeom>
           <a:noFill/>
+          <a:ln/>
         </p:spPr>
         <p:txBody>
           <a:bodyPr wrap="square">
@@ -57096,7 +57097,7 @@
                 <a:solidFill>
                   <a:srgbClr val="FFFFFF"/>
                 </a:solidFill>
-                <a:latin typeface="Segoe UI"/>
+                <a:latin typeface="Arial"/>
               </a:rPr>
               <a:t>JTAG DEBUG COPILOT</a:t>
             </a:r>
@@ -57124,6 +57125,7 @@
             <a:avLst/>
           </a:prstGeom>
           <a:noFill/>
+          <a:ln/>
         </p:spPr>
         <p:txBody>
           <a:bodyPr wrap="square">
@@ -57137,7 +57139,7 @@
                 <a:solidFill>
                   <a:srgbClr val="FFFFFF"/>
                 </a:solidFill>
-                <a:latin typeface="Segoe UI"/>
+                <a:latin typeface="Arial"/>
               </a:rPr>
               <a:t>Agent JTAG Debugging: From Failure to Fix</a:t>
             </a:r>
@@ -57171,7 +57173,7 @@
             <a:avLst/>
           </a:prstGeom>
           <a:solidFill>
-            <a:srgbClr val="FF8C00"/>
+            <a:srgbClr val="D71920"/>
           </a:solidFill>
           <a:ln>
             <a:noFill/>
@@ -57221,7 +57223,7 @@
             <a:avLst/>
           </a:prstGeom>
           <a:solidFill>
-            <a:srgbClr val="0E2A4A"/>
+            <a:srgbClr val="333333"/>
           </a:solidFill>
           <a:ln>
             <a:noFill/>
@@ -57271,6 +57273,7 @@
             <a:avLst/>
           </a:prstGeom>
           <a:noFill/>
+          <a:ln/>
         </p:spPr>
         <p:txBody>
           <a:bodyPr wrap="square">
@@ -57282,11 +57285,11 @@
             <a:r>
               <a:rPr sz="900" b="0" i="0">
                 <a:solidFill>
-                  <a:srgbClr val="6080A8"/>
+                  <a:srgbClr val="B8B8B8"/>
                 </a:solidFill>
-                <a:latin typeface="Segoe UI"/>
+                <a:latin typeface="Arial"/>
               </a:rPr>
-              <a:t>6  /  11</a:t>
+              <a:t>8  /  14</a:t>
             </a:r>
           </a:p>
         </p:txBody>
@@ -57314,7 +57317,7 @@
             </a:avLst>
           </a:prstGeom>
           <a:solidFill>
-            <a:srgbClr val="0B1F3A"/>
+            <a:srgbClr val="2B2B2B"/>
           </a:solidFill>
           <a:ln>
             <a:noFill/>
@@ -58591,7 +58594,7 @@
             <a:avLst/>
           </a:prstGeom>
           <a:solidFill>
-            <a:srgbClr val="0B1F3A"/>
+            <a:srgbClr val="2B2B2B"/>
           </a:solidFill>
           <a:ln>
             <a:noFill/>
@@ -58645,7 +58648,7 @@
             <a:avLst/>
           </a:prstGeom>
           <a:solidFill>
-            <a:srgbClr val="FF8C00"/>
+            <a:srgbClr val="D71920"/>
           </a:solidFill>
           <a:ln>
             <a:noFill/>
@@ -58820,7 +58823,7 @@
             </a:avLst>
           </a:prstGeom>
           <a:solidFill>
-            <a:srgbClr val="0F2845"/>
+            <a:srgbClr val="333333"/>
           </a:solidFill>
           <a:ln>
             <a:noFill/>
@@ -58870,7 +58873,7 @@
             <a:avLst/>
           </a:prstGeom>
           <a:solidFill>
-            <a:srgbClr val="0072C6"/>
+            <a:srgbClr val="D71920"/>
           </a:solidFill>
           <a:ln>
             <a:noFill/>
@@ -58922,7 +58925,7 @@
             </a:avLst>
           </a:prstGeom>
           <a:solidFill>
-            <a:srgbClr val="0F2845"/>
+            <a:srgbClr val="333333"/>
           </a:solidFill>
           <a:ln>
             <a:noFill/>
@@ -58972,6 +58975,7 @@
             <a:avLst/>
           </a:prstGeom>
           <a:noFill/>
+          <a:ln/>
         </p:spPr>
         <p:txBody>
           <a:bodyPr wrap="square">
@@ -58983,9 +58987,9 @@
             <a:r>
               <a:rPr lang="en-US" sz="1100" b="1" i="0" dirty="0">
                 <a:solidFill>
-                  <a:srgbClr val="FF8C00"/>
+                  <a:srgbClr val="D71920"/>
                 </a:solidFill>
-                <a:latin typeface="Segoe UI"/>
+                <a:latin typeface="Arial"/>
               </a:rPr>
               <a:t>JTAG Agent – Real time Use cases</a:t>
             </a:r>
@@ -59011,9 +59015,9 @@
             <a:r>
               <a:rPr lang="en-US" sz="1100" b="1" dirty="0">
                 <a:solidFill>
-                  <a:srgbClr val="00D48A"/>
+                  <a:srgbClr val="2E7D32"/>
                 </a:solidFill>
-                <a:latin typeface="Segoe UI"/>
+                <a:latin typeface="Arial"/>
               </a:rPr>
               <a:t>Bootloader -&gt; Application Handoff Failure (Hard Fault)</a:t>
             </a:r>
@@ -59030,72 +59034,72 @@
             <a:r>
               <a:rPr lang="en-US" sz="1000" b="1" dirty="0">
                 <a:solidFill>
-                  <a:srgbClr val="B8D0EC"/>
+                  <a:srgbClr val="E8E8E8"/>
                 </a:solidFill>
-                <a:latin typeface="Segoe UI"/>
+                <a:latin typeface="Arial"/>
               </a:rPr>
               <a:t>Problem</a:t>
             </a:r>
             <a:r>
               <a:rPr lang="en-US" sz="930" dirty="0">
                 <a:solidFill>
-                  <a:srgbClr val="B8D0EC"/>
+                  <a:srgbClr val="E8E8E8"/>
                 </a:solidFill>
-                <a:latin typeface="Segoe UI"/>
+                <a:latin typeface="Arial"/>
               </a:rPr>
               <a:t>: Bootloader enabled </a:t>
             </a:r>
             <a:r>
               <a:rPr lang="en-US" sz="930" dirty="0" err="1">
                 <a:solidFill>
-                  <a:srgbClr val="B8D0EC"/>
+                  <a:srgbClr val="E8E8E8"/>
                 </a:solidFill>
-                <a:latin typeface="Segoe UI"/>
+                <a:latin typeface="Arial"/>
               </a:rPr>
               <a:t>SysTick</a:t>
             </a:r>
             <a:r>
               <a:rPr lang="en-US" sz="930" dirty="0">
                 <a:solidFill>
-                  <a:srgbClr val="B8D0EC"/>
+                  <a:srgbClr val="E8E8E8"/>
                 </a:solidFill>
-                <a:latin typeface="Segoe UI"/>
+                <a:latin typeface="Arial"/>
               </a:rPr>
               <a:t> timer; application's vector table had no </a:t>
             </a:r>
             <a:r>
               <a:rPr lang="en-US" sz="930" dirty="0" err="1">
                 <a:solidFill>
-                  <a:srgbClr val="B8D0EC"/>
+                  <a:srgbClr val="E8E8E8"/>
                 </a:solidFill>
-                <a:latin typeface="Segoe UI"/>
+                <a:latin typeface="Arial"/>
               </a:rPr>
               <a:t>SysTick</a:t>
             </a:r>
             <a:r>
               <a:rPr lang="en-US" sz="930" dirty="0">
                 <a:solidFill>
-                  <a:srgbClr val="B8D0EC"/>
+                  <a:srgbClr val="E8E8E8"/>
                 </a:solidFill>
-                <a:latin typeface="Segoe UI"/>
+                <a:latin typeface="Arial"/>
               </a:rPr>
               <a:t> handler → </a:t>
             </a:r>
             <a:r>
               <a:rPr lang="en-US" sz="930" dirty="0" err="1">
                 <a:solidFill>
-                  <a:srgbClr val="B8D0EC"/>
+                  <a:srgbClr val="E8E8E8"/>
                 </a:solidFill>
-                <a:latin typeface="Segoe UI"/>
+                <a:latin typeface="Arial"/>
               </a:rPr>
               <a:t>HardFault</a:t>
             </a:r>
             <a:r>
               <a:rPr lang="en-US" sz="930" dirty="0">
                 <a:solidFill>
-                  <a:srgbClr val="B8D0EC"/>
+                  <a:srgbClr val="E8E8E8"/>
                 </a:solidFill>
-                <a:latin typeface="Segoe UI"/>
+                <a:latin typeface="Arial"/>
               </a:rPr>
               <a:t> on jump.</a:t>
             </a:r>
@@ -59112,18 +59116,18 @@
             <a:r>
               <a:rPr lang="en-US" sz="1000" b="1" dirty="0">
                 <a:solidFill>
-                  <a:srgbClr val="B8D0EC"/>
+                  <a:srgbClr val="E8E8E8"/>
                 </a:solidFill>
-                <a:latin typeface="Segoe UI"/>
+                <a:latin typeface="Arial"/>
               </a:rPr>
               <a:t>Solution: </a:t>
             </a:r>
             <a:r>
               <a:rPr lang="en-US" sz="1000" dirty="0">
                 <a:solidFill>
-                  <a:srgbClr val="B8D0EC"/>
+                  <a:srgbClr val="E8E8E8"/>
                 </a:solidFill>
-                <a:latin typeface="Segoe UI"/>
+                <a:latin typeface="Arial"/>
               </a:rPr>
               <a:t>Agent identified root cause in 45 minutes (vs. 2–3 days manual debugging) by correlating PC, vector tables, and peripheral state.</a:t>
             </a:r>
@@ -59148,9 +59152,9 @@
             <a:r>
               <a:rPr lang="en-US" sz="1000" b="1" dirty="0">
                 <a:solidFill>
-                  <a:srgbClr val="00D48A"/>
+                  <a:srgbClr val="2E7D32"/>
                 </a:solidFill>
-                <a:latin typeface="Segoe UI"/>
+                <a:latin typeface="Arial"/>
               </a:rPr>
               <a:t>Emulating sub zero temperature condition at room temperature</a:t>
             </a:r>
@@ -59167,36 +59171,36 @@
             <a:r>
               <a:rPr lang="en-US" sz="1000" b="1" dirty="0">
                 <a:solidFill>
-                  <a:srgbClr val="B8D0EC"/>
+                  <a:srgbClr val="E8E8E8"/>
                 </a:solidFill>
-                <a:latin typeface="Segoe UI"/>
+                <a:latin typeface="Arial"/>
               </a:rPr>
               <a:t>Problem: </a:t>
             </a:r>
             <a:r>
               <a:rPr lang="en-US" sz="1000" dirty="0">
                 <a:solidFill>
-                  <a:srgbClr val="B8D0EC"/>
+                  <a:srgbClr val="E8E8E8"/>
                 </a:solidFill>
-                <a:latin typeface="Segoe UI"/>
+                <a:latin typeface="Arial"/>
               </a:rPr>
               <a:t>ADC stalled at negative temperature; fix required driver </a:t>
             </a:r>
             <a:r>
               <a:rPr lang="en-US" sz="1000" dirty="0" err="1">
                 <a:solidFill>
-                  <a:srgbClr val="B8D0EC"/>
+                  <a:srgbClr val="E8E8E8"/>
                 </a:solidFill>
-                <a:latin typeface="Segoe UI"/>
+                <a:latin typeface="Arial"/>
               </a:rPr>
               <a:t>reinit</a:t>
             </a:r>
             <a:r>
               <a:rPr lang="en-US" sz="1000" dirty="0">
                 <a:solidFill>
-                  <a:srgbClr val="B8D0EC"/>
+                  <a:srgbClr val="E8E8E8"/>
                 </a:solidFill>
-                <a:latin typeface="Segoe UI"/>
+                <a:latin typeface="Arial"/>
               </a:rPr>
               <a:t> with gain adjustment.</a:t>
             </a:r>
@@ -59213,18 +59217,18 @@
             <a:r>
               <a:rPr lang="en-US" sz="1000" b="1" dirty="0">
                 <a:solidFill>
-                  <a:srgbClr val="B8D0EC"/>
+                  <a:srgbClr val="E8E8E8"/>
                 </a:solidFill>
-                <a:latin typeface="Segoe UI"/>
+                <a:latin typeface="Arial"/>
               </a:rPr>
               <a:t>Solution: </a:t>
             </a:r>
             <a:r>
               <a:rPr lang="en-US" sz="1000" dirty="0">
                 <a:solidFill>
-                  <a:srgbClr val="B8D0EC"/>
+                  <a:srgbClr val="E8E8E8"/>
                 </a:solidFill>
-                <a:latin typeface="Segoe UI"/>
+                <a:latin typeface="Arial"/>
               </a:rPr>
               <a:t>Agent simulated cold ADC state at 25°C, enabling root-cause fix and validation without thermal chamber—saved 1 week of thermal cycling.</a:t>
             </a:r>
@@ -59241,9 +59245,9 @@
             <a:r>
               <a:rPr lang="en-US" sz="1000" b="1" dirty="0">
                 <a:solidFill>
-                  <a:srgbClr val="00D48A"/>
+                  <a:srgbClr val="2E7D32"/>
                 </a:solidFill>
-                <a:latin typeface="Segoe UI"/>
+                <a:latin typeface="Arial"/>
               </a:rPr>
               <a:t>Boot Failure due to Incorrect Boot Configuration</a:t>
             </a:r>
@@ -59252,18 +59256,18 @@
             <a:r>
               <a:rPr lang="en-US" sz="1000" b="1" dirty="0">
                 <a:solidFill>
-                  <a:srgbClr val="B8D0EC"/>
+                  <a:srgbClr val="E8E8E8"/>
                 </a:solidFill>
-                <a:latin typeface="Segoe UI"/>
+                <a:latin typeface="Arial"/>
               </a:rPr>
               <a:t>Problem: </a:t>
             </a:r>
             <a:r>
               <a:rPr lang="en-US" sz="1000" dirty="0">
                 <a:solidFill>
-                  <a:srgbClr val="B8D0EC"/>
+                  <a:srgbClr val="E8E8E8"/>
                 </a:solidFill>
-                <a:latin typeface="Segoe UI"/>
+                <a:latin typeface="Arial"/>
               </a:rPr>
               <a:t>Device failed to boot into application after flashing new build on new hardware, all looked good.</a:t>
             </a:r>
@@ -59280,18 +59284,18 @@
             <a:r>
               <a:rPr lang="en-US" sz="1000" b="1" dirty="0">
                 <a:solidFill>
-                  <a:srgbClr val="B8D0EC"/>
+                  <a:srgbClr val="E8E8E8"/>
                 </a:solidFill>
-                <a:latin typeface="Segoe UI"/>
+                <a:latin typeface="Arial"/>
               </a:rPr>
               <a:t>Solution: </a:t>
             </a:r>
             <a:r>
               <a:rPr lang="en-US" sz="1000" dirty="0">
                 <a:solidFill>
-                  <a:srgbClr val="B8D0EC"/>
+                  <a:srgbClr val="E8E8E8"/>
                 </a:solidFill>
-                <a:latin typeface="Segoe UI"/>
+                <a:latin typeface="Arial"/>
               </a:rPr>
               <a:t>Agent traced Program Counter (PC) and identified execution redirecting to system ROM instead of internal flash.</a:t>
             </a:r>
@@ -59400,32 +59404,110 @@
             <a:avLst/>
           </a:prstGeom>
           <a:solidFill>
-            <a:srgbClr val="00D48A"/>
-          </a:solidFill>
-          <a:ln>
-            <a:noFill/>
-          </a:ln>
-        </p:spPr>
-        <p:style>
-          <a:lnRef idx="1">
-            <a:schemeClr val="accent1"/>
-          </a:lnRef>
-          <a:fillRef idx="3">
-            <a:schemeClr val="accent1"/>
-          </a:fillRef>
-          <a:effectRef idx="2">
-            <a:schemeClr val="accent1"/>
-          </a:effectRef>
-          <a:fontRef idx="minor">
-            <a:schemeClr val="lt1"/>
-          </a:fontRef>
-        </p:style>
-        <p:txBody>
-          <a:bodyPr rtlCol="0" anchor="ctr"/>
-          <a:lstStyle/>
-          <a:p>
-            <a:pPr algn="ctr"/>
-            <a:endParaRPr/>
+            <a:srgbClr val="2E7D32"/>
+          </a:solidFill>
+          <a:ln>
+            <a:noFill/>
+          </a:ln>
+        </p:spPr>
+        <p:style>
+          <a:lnRef idx="1">
+            <a:schemeClr val="accent1"/>
+          </a:lnRef>
+          <a:fillRef idx="3">
+            <a:schemeClr val="accent1"/>
+          </a:fillRef>
+          <a:effectRef idx="2">
+            <a:schemeClr val="accent1"/>
+          </a:effectRef>
+          <a:fontRef idx="minor">
+            <a:schemeClr val="lt1"/>
+          </a:fontRef>
+        </p:style>
+        <p:txBody>
+          <a:bodyPr rtlCol="0" anchor="ctr"/>
+          <a:lstStyle/>
+          <a:p>
+            <a:pPr algn="ctr"/>
+            <a:endParaRPr/>
+          </a:p>
+        </p:txBody>
+      </p:sp>
+      <p:sp>
+        <p:nvSpPr>
+          <p:cNvPr id="130" name="Rectangle 129"/>
+          <p:cNvSpPr/>
+          <p:nvPr/>
+        </p:nvSpPr>
+        <p:spPr>
+          <a:xfrm>
+            <a:off x="0" y="0"/>
+            <a:ext cx="9144000" cy="32004"/>
+          </a:xfrm>
+          <a:prstGeom prst="rect">
+            <a:avLst/>
+          </a:prstGeom>
+          <a:solidFill>
+            <a:srgbClr val="D71920"/>
+          </a:solidFill>
+          <a:ln>
+            <a:noFill/>
+          </a:ln>
+        </p:spPr>
+        <p:style>
+          <a:lnRef idx="1">
+            <a:schemeClr val="accent1"/>
+          </a:lnRef>
+          <a:fillRef idx="3">
+            <a:schemeClr val="accent1"/>
+          </a:fillRef>
+          <a:effectRef idx="2">
+            <a:schemeClr val="accent1"/>
+          </a:effectRef>
+          <a:fontRef idx="minor">
+            <a:schemeClr val="lt1"/>
+          </a:fontRef>
+        </p:style>
+        <p:txBody>
+          <a:bodyPr rtlCol="0" anchor="ctr"/>
+          <a:lstStyle/>
+          <a:p>
+            <a:pPr algn="ctr"/>
+          </a:p>
+        </p:txBody>
+      </p:sp>
+      <p:sp>
+        <p:nvSpPr>
+          <p:cNvPr id="131" name="TextBox 130"/>
+          <p:cNvSpPr txBox="1"/>
+          <p:nvPr/>
+        </p:nvSpPr>
+        <p:spPr>
+          <a:xfrm>
+            <a:off x="7699248" y="118872"/>
+            <a:ext cx="1170432" cy="201168"/>
+          </a:xfrm>
+          <a:prstGeom prst="rect">
+            <a:avLst/>
+          </a:prstGeom>
+          <a:noFill/>
+        </p:spPr>
+        <p:txBody>
+          <a:bodyPr wrap="none">
+            <a:spAutoFit/>
+          </a:bodyPr>
+          <a:lstStyle/>
+          <a:p>
+            <a:pPr algn="r"/>
+            <a:r>
+              <a:rPr b="1" sz="1000">
+                <a:solidFill>
+                  <a:srgbClr val="D71920"/>
+                </a:solidFill>
+                <a:latin typeface="Arial"/>
+              </a:rPr>
+              <a:t>HONEYWELL</a:t>
+            </a:r>
           </a:p>
         </p:txBody>
       </p:sp>

</xml_diff>